<commit_message>
Document verified Grafana centre, successful CI deployment and reserved holdout evidence
</commit_message>
<xml_diff>
--- a/docs/DDM501_Face_Voice_Proctoring.pptx
+++ b/docs/DDM501_Face_Voice_Proctoring.pptx
@@ -4545,7 +4545,7 @@
               </a:defRPr>
             </a:pPr>
             <a:r>
-              <a:t>Coverage phạm vi API + monitoring + evaluation gates: 83.78%.</a:t>
+              <a:t>Coverage phạm vi API + monitoring + evaluation gates: 88.76%.</a:t>
             </a:r>
           </a:p>
           <a:p>
@@ -4577,7 +4577,7 @@
               </a:defRPr>
             </a:pPr>
             <a:r>
-              <a:t>Grafana queries / reports / alert delivery: chưa chạy.</a:t>
+              <a:t>Grafana queries / reports / alert delivery: pass.</a:t>
             </a:r>
           </a:p>
           <a:p>
@@ -4593,7 +4593,7 @@
               </a:defRPr>
             </a:pPr>
             <a:r>
-              <a:t>Recovery drill: chưa chạy.</a:t>
+              <a:t>Recovery drill: pass.</a:t>
             </a:r>
           </a:p>
           <a:p>
@@ -4609,7 +4609,7 @@
               </a:defRPr>
             </a:pPr>
             <a:r>
-              <a:t>GitHub Actions gần nhất: completed / failure.</a:t>
+              <a:t>GitHub Actions gần nhất: completed / success.</a:t>
             </a:r>
           </a:p>
         </p:txBody>
@@ -6410,7 +6410,7 @@
               </a:defRPr>
             </a:pPr>
             <a:r>
-              <a:t>Five-fold identity split; holdout không dùng để tune threshold.</a:t>
+              <a:t>Five-way identity split: holdout riêng + 4 folds CV nội bộ.</a:t>
             </a:r>
           </a:p>
           <a:p>

</xml_diff>

<commit_message>
Align company integration, reports and business documentation with approved service scope
</commit_message>
<xml_diff>
--- a/docs/DDM501_Face_Voice_Proctoring.pptx
+++ b/docs/DDM501_Face_Voice_Proctoring.pptx
@@ -4545,7 +4545,7 @@
               </a:defRPr>
             </a:pPr>
             <a:r>
-              <a:t>Coverage phạm vi API + monitoring + evaluation gates: 88.76%.</a:t>
+              <a:t>Coverage phạm vi API + monitoring + evaluation gates: 85.80%.</a:t>
             </a:r>
           </a:p>
           <a:p>
@@ -5976,7 +5976,7 @@
               </a:defRPr>
             </a:pPr>
             <a:r>
-              <a:t>REST + sessions + outbox</a:t>
+              <a:t>Batch API + evidence</a:t>
             </a:r>
           </a:p>
         </p:txBody>

</xml_diff>

<commit_message>
Preserve Vietnamese documentation and update customer batch demo presentation
</commit_message>
<xml_diff>
--- a/docs/DDM501_Face_Voice_Proctoring.pptx
+++ b/docs/DDM501_Face_Voice_Proctoring.pptx
@@ -513,7 +513,7 @@
           <a:lstStyle/>
           <a:p>
             <a:r>
-              <a:t>1 phút. Điền tên thật của nhóm trên slide nếu có. Giới thiệu xác minh 1:1, uncertain thì human review. Không tuyên bố phát hiện gian lận hoặc production accuracy.</a:t>
+              <a:t>1 phút. Điền tên thật của nhóm trên slide nếu có. Giới thiệu batch API và portal công ty. Capability limits rõ ràng; không công bố production accuracy.</a:t>
             </a:r>
           </a:p>
         </p:txBody>
@@ -1073,7 +1073,7 @@
           <a:lstStyle/>
           <a:p>
             <a:r>
-              <a:t>2,5 phút. Mở legacy :18600 và portal :18501. Vào thi trước xác minh bị chặn. Upload demo đúng/sai. Kiểm tra callback không tin client success=true. Browser camera/microphone cần người dùng chấp nhận quyền và test trên thiết bị thật.</a:t>
+              <a:t>2,5 phút. Mở customer demo :18600 và portal :18501. Ghi danh, gọi batch check, kiểm tra webhook và bằng chứng, xuất PDF/CSV. Quyết định thi thuộc khách hàng. Browser camera/microphone cần người dùng chấp nhận quyền và test trên thiết bị thật.</a:t>
             </a:r>
           </a:p>
         </p:txBody>
@@ -1283,7 +1283,7 @@
           <a:lstStyle/>
           <a:p>
             <a:r>
-              <a:t>1,5 phút. Quality slice là proxy vận hành, không chứng minh demographic fairness. Policy explanation không phải lời giải thích causal cho embedding. Chưa liveness/audio anti-spoof; media đã enroll có score cao không chứng minh khả năng generalize.</a:t>
+              <a:t>1,5 phút. Quality slice là proxy vận hành, không chứng minh demographic fairness. Policy explanation không phải lời giải thích causal cho embedding. PAD/AASIST chưa có benchmark khách hàng; media đã enroll có score cao không chứng minh khả năng generalize.</a:t>
             </a:r>
           </a:p>
         </p:txBody>
@@ -4370,7 +4370,7 @@
               </a:defRPr>
             </a:pPr>
             <a:r>
-              <a:t>SaaS xác minh danh tính cho thi trực tuyến</a:t>
+              <a:t>API xác minh nhân viên trong kỳ đánh giá ngoại ngữ</a:t>
             </a:r>
           </a:p>
           <a:p>
@@ -4545,7 +4545,7 @@
               </a:defRPr>
             </a:pPr>
             <a:r>
-              <a:t>Coverage phạm vi API + monitoring + evaluation gates: 85.80%.</a:t>
+              <a:t>Coverage phạm vi API + monitoring + evaluation gates: 86.39%.</a:t>
             </a:r>
           </a:p>
           <a:p>
@@ -4768,7 +4768,7 @@
               </a:defRPr>
             </a:pPr>
             <a:r>
-              <a:t>Chi phí: compute + DB + storage + egress + human review.</a:t>
+              <a:t>Chi phí: compute + DB + suspicious evidence + egress.</a:t>
             </a:r>
           </a:p>
           <a:p>
@@ -4800,7 +4800,7 @@
               </a:defRPr>
             </a:pPr>
             <a:r>
-              <a:t>Cloud/TLS/SSO và anti-spoof cần thêm phạm vi triển khai.</a:t>
+              <a:t>PAD/AASIST có inference; cần benchmark và cloud/TLS/SSO.</a:t>
             </a:r>
           </a:p>
         </p:txBody>
@@ -5134,7 +5134,7 @@
               </a:defRPr>
             </a:pPr>
             <a:r>
-              <a:t>Đối tác tích hợp hosted verification và signed callbacks.</a:t>
+              <a:t>Công ty có phần mềm thi và chấm điểm riêng.</a:t>
             </a:r>
           </a:p>
           <a:p>
@@ -5150,7 +5150,7 @@
               </a:defRPr>
             </a:pPr>
             <a:r>
-              <a:t>Giám thị xử lý REVIEW; quyết định gốc được giữ nguyên.</a:t>
+              <a:t>Dịch vụ nhận ảnh/WAV theo nhịp do khách hàng cấu hình.</a:t>
             </a:r>
           </a:p>
           <a:p>
@@ -5166,7 +5166,7 @@
               </a:defRPr>
             </a:pPr>
             <a:r>
-              <a:t>Pilot targets: ≥70% genuine auto-allow; giảm ≥50% thời gian review.</a:t>
+              <a:t>API/webhook trả identity và integrity signals.</a:t>
             </a:r>
           </a:p>
           <a:p>
@@ -5182,7 +5182,7 @@
               </a:defRPr>
             </a:pPr>
             <a:r>
-              <a:t>Đo FAR, FRR, p95 ≤2s và review turnaround &lt;15 phút.</a:t>
+              <a:t>Admin công ty xem lịch sử, bằng chứng và PDF/CSV.</a:t>
             </a:r>
           </a:p>
         </p:txBody>
@@ -6546,7 +6546,7 @@
               </a:defRPr>
             </a:pPr>
             <a:r>
-              <a:t>SaaS serving và demo tích hợp</a:t>
+              <a:t>Batch serving và portal doanh nghiệp</a:t>
             </a:r>
           </a:p>
         </p:txBody>
@@ -6601,7 +6601,7 @@
               </a:defRPr>
             </a:pPr>
             <a:r>
-              <a:t>Session có expiry, consent và token dùng một lần.</a:t>
+              <a:t>Batch có consent, request_id và lịch sử bất biến.</a:t>
             </a:r>
           </a:p>
           <a:p>
@@ -6617,7 +6617,7 @@
               </a:defRPr>
             </a:pPr>
             <a:r>
-              <a:t>Backend đối tác nhận callback HMAC + sequence + dedup.</a:t>
+              <a:t>Callback HMAC + outbox + retry + dedup.</a:t>
             </a:r>
           </a:p>
           <a:p>
@@ -6633,7 +6633,7 @@
               </a:defRPr>
             </a:pPr>
             <a:r>
-              <a:t>Demo: genuine → ALLOW; impostor → REVIEW → operator quyết định.</a:t>
+              <a:t>Demo hai công ty: identity đúng/sai, evidence và export.</a:t>
             </a:r>
           </a:p>
         </p:txBody>

</xml_diff>

<commit_message>
Verify customer callbacks, separate capture limits from outages and record maintenance evidence
</commit_message>
<xml_diff>
--- a/docs/DDM501_Face_Voice_Proctoring.pptx
+++ b/docs/DDM501_Face_Voice_Proctoring.pptx
@@ -4545,7 +4545,7 @@
               </a:defRPr>
             </a:pPr>
             <a:r>
-              <a:t>Coverage phạm vi API + monitoring + evaluation gates: 86.39%.</a:t>
+              <a:t>Coverage phạm vi API + monitoring + evaluation gates: 86.50%.</a:t>
             </a:r>
           </a:p>
           <a:p>
@@ -6808,7 +6808,7 @@
               </a:defRPr>
             </a:pPr>
             <a:r>
-              <a:t>Sessions/review SLA · webhooks · Airflow/RAI · CPU/RAM/logs</a:t>
+              <a:t>Batch/detector/evidence · webhooks · Airflow/RAI · CPU/RAM/logs</a:t>
             </a:r>
           </a:p>
           <a:p>

</xml_diff>